<commit_message>
Reframe deck around recovery, add team member Ronnit Mirgh
- Shift narrative from incident reconstruction to recovery-action
  validity (R2Act gap: 43.8% invalid vs Metis 0%)
- Add team member Ronnit Mirgh to slide 1
- Lead with recovery in every slide: idea, opportunities, features,
  process flow, architecture, benchmarks, and future development

Co-Authored-By: Claude Opus 4.6 <noreply@anthropic.com>
Claude-Session: https://claude.ai/code/session_01DCNQxqhda7dH1EwN5Sf3Ug
</commit_message>
<xml_diff>
--- a/MetisRealityGraph.pptx
+++ b/MetisRealityGraph.pptx
@@ -7113,7 +7113,7 @@
                 <a:cs typeface="Google Sans Flex"/>
                 <a:sym typeface="Google Sans Flex"/>
               </a:rPr>
-              <a:t>Problem Statement: Future of Work &amp; Enterprise Productivity</a:t>
+              <a:t>Team member: Ronnit Mirgh</a:t>
             </a:r>
             <a:endParaRPr sz="1800">
               <a:latin typeface="Google Sans Flex"/>
@@ -7123,23 +7123,31 @@
             </a:endParaRPr>
           </a:p>
           <a:p>
-            <a:pPr indent="0" lvl="0" marL="0" rtl="0" algn="l">
-              <a:spcBef>
-                <a:spcPts val="0"/>
-              </a:spcBef>
-              <a:spcAft>
-                <a:spcPts val="0"/>
-              </a:spcAft>
-              <a:buNone/>
-            </a:pPr>
-            <a:r>
-              <a:t/>
+            <a:pPr indent="-311150" lvl="0" marL="457200" rtl="0" algn="l">
+              <a:spcBef>
+                <a:spcPts val="0"/>
+              </a:spcBef>
+              <a:spcAft>
+                <a:spcPts val="400"/>
+              </a:spcAft>
+              <a:buSzPts val="1800"/>
+              <a:buFont typeface="Google Sans Flex"/>
+              <a:buChar char="●"/>
+            </a:pPr>
+            <a:r>
+              <a:rPr lang="en-GB" sz="1800">
+                <a:latin typeface="Google Sans Flex"/>
+                <a:ea typeface="Google Sans Flex"/>
+                <a:cs typeface="Google Sans Flex"/>
+                <a:sym typeface="Google Sans Flex"/>
+              </a:rPr>
+              <a:t>Problem Statement: Future of Work &amp; Enterprise Productivity</a:t>
             </a:r>
             <a:endParaRPr sz="1800">
-              <a:latin typeface="Google Sans Flex Medium"/>
-              <a:ea typeface="Google Sans Flex Medium"/>
-              <a:cs typeface="Google Sans Flex Medium"/>
-              <a:sym typeface="Google Sans Flex Medium"/>
+              <a:latin typeface="Google Sans Flex"/>
+              <a:ea typeface="Google Sans Flex"/>
+              <a:cs typeface="Google Sans Flex"/>
+              <a:sym typeface="Google Sans Flex"/>
             </a:endParaRPr>
           </a:p>
         </p:txBody>
@@ -7437,7 +7445,7 @@
                 <a:cs typeface="Google Sans Flex"/>
                 <a:sym typeface="Google Sans Flex"/>
               </a:rPr>
-              <a:t>Cloud Run: ~$0/month (within free tier for demo traffic, scales to zero)</a:t>
+              <a:t>Cloud Run: ~$0/month (within free tier for demo traffic, scales to zero when idle)</a:t>
             </a:r>
             <a:endParaRPr sz="1300">
               <a:latin typeface="Google Sans Flex"/>
@@ -7548,6 +7556,34 @@
                 <a:sym typeface="Google Sans Flex"/>
               </a:rPr>
               <a:t>Gemini 3.8 Flash: pay-per-use, ~$0.01–0.05 per investigation call</a:t>
+            </a:r>
+            <a:endParaRPr sz="1300">
+              <a:latin typeface="Google Sans Flex"/>
+              <a:ea typeface="Google Sans Flex"/>
+              <a:cs typeface="Google Sans Flex"/>
+              <a:sym typeface="Google Sans Flex"/>
+            </a:endParaRPr>
+          </a:p>
+          <a:p>
+            <a:pPr indent="-311150" lvl="0" marL="457200" rtl="0" algn="l">
+              <a:spcBef>
+                <a:spcPts val="0"/>
+              </a:spcBef>
+              <a:spcAft>
+                <a:spcPts val="200"/>
+              </a:spcAft>
+              <a:buSzPts val="1300"/>
+              <a:buFont typeface="Google Sans Flex"/>
+              <a:buChar char="●"/>
+            </a:pPr>
+            <a:r>
+              <a:rPr lang="en-GB" sz="1300">
+                <a:latin typeface="Google Sans Flex"/>
+                <a:ea typeface="Google Sans Flex"/>
+                <a:cs typeface="Google Sans Flex"/>
+                <a:sym typeface="Google Sans Flex"/>
+              </a:rPr>
+              <a:t>Recovery action selection is deterministic — no additional AI cost</a:t>
             </a:r>
             <a:endParaRPr sz="1300">
               <a:latin typeface="Google Sans Flex"/>
@@ -7880,7 +7916,7 @@
                 <a:cs typeface="Google Sans Flex"/>
                 <a:sym typeface="Google Sans Flex"/>
               </a:rPr>
-              <a:t>Main Dashboard: M3-styled interface showing incident list sidebar with status counts, interactive timeline with evidence records and incident markers</a:t>
+              <a:t>Main Dashboard: M3-styled interface showing incident list with status counts, interactive evidence timeline, and recovery recommendations</a:t>
             </a:r>
             <a:endParaRPr sz="1300">
               <a:latin typeface="Google Sans Flex"/>
@@ -7908,7 +7944,7 @@
                 <a:cs typeface="Google Sans Flex"/>
                 <a:sym typeface="Google Sans Flex"/>
               </a:rPr>
-              <a:t>Investigation View: Gemini investigation results with structured JSON output, evidence citations, and admissibility check results</a:t>
+              <a:t>Recovery View: state-aware recovery action with validity status and state justification — shows exactly why a rollback/deploy/no-action is safe or unsafe</a:t>
             </a:r>
             <a:endParaRPr sz="1300">
               <a:latin typeface="Google Sans Flex"/>
@@ -7936,7 +7972,7 @@
                 <a:cs typeface="Google Sans Flex"/>
                 <a:sym typeface="Google Sans Flex"/>
               </a:rPr>
-              <a:t>Custom Composer: Interactive form to build custom incidents with commit, build, deploy, and runtime records. Tests the full pipeline live.</a:t>
+              <a:t>Investigation View: Gemini analysis results with structured evidence citations and admissibility check</a:t>
             </a:r>
             <a:endParaRPr sz="1300">
               <a:latin typeface="Google Sans Flex"/>
@@ -7964,7 +8000,35 @@
                 <a:cs typeface="Google Sans Flex"/>
                 <a:sym typeface="Google Sans Flex"/>
               </a:rPr>
-              <a:t>Time Travel: Three temporal views — 30 min before incident, at incident time, and 30 min after — showing how evidence state changes</a:t>
+              <a:t>Custom Composer: build custom incidents with commit, build, deploy, and runtime records — test the full recovery pipeline live</a:t>
+            </a:r>
+            <a:endParaRPr sz="1300">
+              <a:latin typeface="Google Sans Flex"/>
+              <a:ea typeface="Google Sans Flex"/>
+              <a:cs typeface="Google Sans Flex"/>
+              <a:sym typeface="Google Sans Flex"/>
+            </a:endParaRPr>
+          </a:p>
+          <a:p>
+            <a:pPr indent="-311150" lvl="0" marL="457200" rtl="0" algn="l">
+              <a:spcBef>
+                <a:spcPts val="0"/>
+              </a:spcBef>
+              <a:spcAft>
+                <a:spcPts val="300"/>
+              </a:spcAft>
+              <a:buSzPts val="1300"/>
+              <a:buFont typeface="Google Sans Flex"/>
+              <a:buChar char="●"/>
+            </a:pPr>
+            <a:r>
+              <a:rPr lang="en-GB" sz="1300">
+                <a:latin typeface="Google Sans Flex"/>
+                <a:ea typeface="Google Sans Flex"/>
+                <a:cs typeface="Google Sans Flex"/>
+                <a:sym typeface="Google Sans Flex"/>
+              </a:rPr>
+              <a:t>Time Travel: see how recovery options change across 30 min before, at, and 30 min after incident time</a:t>
             </a:r>
             <a:endParaRPr sz="1300">
               <a:latin typeface="Google Sans Flex"/>
@@ -8233,7 +8297,7 @@
                 <a:cs typeface="Google Sans Flex SemiBold"/>
                 <a:sym typeface="Google Sans Flex SemiBold"/>
               </a:rPr>
-              <a:t>Investigation Benchmark (16 scenarios, Gemini 3.8 Flash, each run twice per mode)</a:t>
+              <a:t>Recovery-Action Validity (our primary metric, closing the R2Act gap)</a:t>
             </a:r>
             <a:endParaRPr sz="1300">
               <a:latin typeface="Google Sans Flex SemiBold"/>
@@ -8261,7 +8325,7 @@
                 <a:cs typeface="Google Sans Flex"/>
                 <a:sym typeface="Google Sans Flex"/>
               </a:rPr>
-              <a:t>Gemini with raw evidence: 19/24 correct cause, 8/8 correct abstain, 0 wrong attributions, 5 missed</a:t>
+              <a:t>Naive always-rollback on v2 (32 scenarios): 43.8% invalid recovery actions (within R2Act range of 39.5–62%)</a:t>
             </a:r>
             <a:endParaRPr sz="1300">
               <a:latin typeface="Google Sans Flex"/>
@@ -8289,7 +8353,7 @@
                 <a:cs typeface="Google Sans Flex"/>
                 <a:sym typeface="Google Sans Flex"/>
               </a:rPr>
-              <a:t>Gemini + reconciliation: 24/24 correct cause, 8/8 correct abstain, 0 wrong, 0 missed</a:t>
+              <a:t>Metis with reconciled state on v2 (32 scenarios): 0% invalid recovery actions — 32/32 valid</a:t>
             </a:r>
             <a:endParaRPr sz="1300">
               <a:latin typeface="Google Sans Flex"/>
@@ -8317,7 +8381,7 @@
                 <a:cs typeface="Google Sans Flex"/>
                 <a:sym typeface="Google Sans Flex"/>
               </a:rPr>
-              <a:t>Across all 96 runs: 0 wrong attributions, 0 fabricated citations, 0 followed injected instruction</a:t>
+              <a:t>Recovery validation is deterministic and state-only — no LLM needed, no hallucination risk</a:t>
             </a:r>
             <a:endParaRPr sz="1300">
               <a:latin typeface="Google Sans Flex"/>
@@ -8343,7 +8407,7 @@
                 <a:cs typeface="Google Sans Flex SemiBold"/>
                 <a:sym typeface="Google Sans Flex SemiBold"/>
               </a:rPr>
-              <a:t>Recovery-Action Validity (R2Act gap)</a:t>
+              <a:t>Investigation Benchmark (16 scenarios, Gemini 3.8 Flash, each run twice per mode)</a:t>
             </a:r>
             <a:endParaRPr sz="1300">
               <a:latin typeface="Google Sans Flex SemiBold"/>
@@ -8371,7 +8435,7 @@
                 <a:cs typeface="Google Sans Flex"/>
                 <a:sym typeface="Google Sans Flex"/>
               </a:rPr>
-              <a:t>Naive always-rollback on v2 (32 scenarios): 43.8% invalid actions (within R2Act range)</a:t>
+              <a:t>Gemini with raw evidence: 19/24 correct cause, 0 wrong attributions, 5 missed answers</a:t>
             </a:r>
             <a:endParaRPr sz="1300">
               <a:latin typeface="Google Sans Flex"/>
@@ -8399,7 +8463,7 @@
                 <a:cs typeface="Google Sans Flex"/>
                 <a:sym typeface="Google Sans Flex"/>
               </a:rPr>
-              <a:t>Metis with reconciled state on v2 (32 scenarios): 0% invalid actions (32/32 valid)</a:t>
+              <a:t>Gemini + reconciliation: 24/24 correct cause, 0 wrong attributions, 0 missed answers</a:t>
             </a:r>
             <a:endParaRPr sz="1300">
               <a:latin typeface="Google Sans Flex"/>
@@ -8427,7 +8491,7 @@
                 <a:cs typeface="Google Sans Flex"/>
                 <a:sym typeface="Google Sans Flex"/>
               </a:rPr>
-              <a:t>Validity check is deterministic and state-only — no LLM needed for recovery actions</a:t>
+              <a:t>Across all 96 runs: 0 fabricated citations, 0 blame on undeployed changes, 0 followed injected instruction</a:t>
             </a:r>
             <a:endParaRPr sz="1300">
               <a:latin typeface="Google Sans Flex"/>
@@ -8481,7 +8545,7 @@
                 <a:cs typeface="Google Sans Flex"/>
                 <a:sym typeface="Google Sans Flex"/>
               </a:rPr>
-              <a:t>We wrote the scenarios. Small sample. Admissibility check never fired on real Gemini output. Synthetic data only.</a:t>
+              <a:t>We wrote the scenarios. Small sample. Synthetic data only. Admissibility check never fired on real Gemini output.</a:t>
             </a:r>
             <a:endParaRPr sz="1300">
               <a:latin typeface="Google Sans Flex"/>
@@ -8786,7 +8850,7 @@
                 <a:cs typeface="Google Sans Flex"/>
                 <a:sym typeface="Google Sans Flex"/>
               </a:rPr>
-              <a:t>A well-prompted Gemini already avoided the dangerous failures we tested.</a:t>
+              <a:t>Recovery validity measured only on deterministic actions, not Gemini-selected ones.</a:t>
             </a:r>
             <a:endParaRPr sz="1300">
               <a:latin typeface="Google Sans Flex"/>
@@ -8814,7 +8878,7 @@
                 <a:cs typeface="Google Sans Flex"/>
                 <a:sym typeface="Google Sans Flex"/>
               </a:rPr>
-              <a:t>Synthetic data only; no real incidents; one model; no measurement of investigation time.</a:t>
+              <a:t>Synthetic data only; no real incidents; one model; no measurement of recovery time savings.</a:t>
             </a:r>
             <a:endParaRPr sz="1300">
               <a:latin typeface="Google Sans Flex"/>
@@ -8868,7 +8932,7 @@
                 <a:cs typeface="Google Sans Flex"/>
                 <a:sym typeface="Google Sans Flex"/>
               </a:rPr>
-              <a:t>Run Gemini on harder v2 adversarial scenario set (32 types) with prompt v2</a:t>
+              <a:t>Measure recovery-action validity with Gemini-selected actions (not just deterministic)</a:t>
             </a:r>
             <a:endParaRPr sz="1300">
               <a:latin typeface="Google Sans Flex"/>
@@ -8896,7 +8960,35 @@
                 <a:cs typeface="Google Sans Flex"/>
                 <a:sym typeface="Google Sans Flex"/>
               </a:rPr>
-              <a:t>Integrate with real incident management systems (PagerDuty, Opsgenie)</a:t>
+              <a:t>Run Gemini on harder v2 adversarial set (32 types) with prompt v2</a:t>
+            </a:r>
+            <a:endParaRPr sz="1300">
+              <a:latin typeface="Google Sans Flex"/>
+              <a:ea typeface="Google Sans Flex"/>
+              <a:cs typeface="Google Sans Flex"/>
+              <a:sym typeface="Google Sans Flex"/>
+            </a:endParaRPr>
+          </a:p>
+          <a:p>
+            <a:pPr indent="-311150" lvl="0" marL="457200" rtl="0" algn="l">
+              <a:spcBef>
+                <a:spcPts val="0"/>
+              </a:spcBef>
+              <a:spcAft>
+                <a:spcPts val="200"/>
+              </a:spcAft>
+              <a:buSzPts val="1300"/>
+              <a:buFont typeface="Google Sans Flex"/>
+              <a:buChar char="●"/>
+            </a:pPr>
+            <a:r>
+              <a:rPr lang="en-GB" sz="1300">
+                <a:latin typeface="Google Sans Flex"/>
+                <a:ea typeface="Google Sans Flex"/>
+                <a:cs typeface="Google Sans Flex"/>
+                <a:sym typeface="Google Sans Flex"/>
+              </a:rPr>
+              <a:t>Integrate with real incident management systems (PagerDuty, Opsgenie) for live recovery workflows</a:t>
             </a:r>
             <a:endParaRPr sz="1300">
               <a:latin typeface="Google Sans Flex"/>
@@ -8952,35 +9044,7 @@
                 <a:cs typeface="Google Sans Flex"/>
                 <a:sym typeface="Google Sans Flex"/>
               </a:rPr>
-              <a:t>Measure recovery-action validity with Gemini-selected actions (not just deterministic)</a:t>
-            </a:r>
-            <a:endParaRPr sz="1300">
-              <a:latin typeface="Google Sans Flex"/>
-              <a:ea typeface="Google Sans Flex"/>
-              <a:cs typeface="Google Sans Flex"/>
-              <a:sym typeface="Google Sans Flex"/>
-            </a:endParaRPr>
-          </a:p>
-          <a:p>
-            <a:pPr indent="-311150" lvl="0" marL="457200" rtl="0" algn="l">
-              <a:spcBef>
-                <a:spcPts val="0"/>
-              </a:spcBef>
-              <a:spcAft>
-                <a:spcPts val="200"/>
-              </a:spcAft>
-              <a:buSzPts val="1300"/>
-              <a:buFont typeface="Google Sans Flex"/>
-              <a:buChar char="●"/>
-            </a:pPr>
-            <a:r>
-              <a:rPr lang="en-GB" sz="1300">
-                <a:latin typeface="Google Sans Flex"/>
-                <a:ea typeface="Google Sans Flex"/>
-                <a:cs typeface="Google Sans Flex"/>
-                <a:sym typeface="Google Sans Flex"/>
-              </a:rPr>
-              <a:t>Test on real incidents from partner organizations</a:t>
+              <a:t>Test on real incidents and measure actual recovery time reduction</a:t>
             </a:r>
             <a:endParaRPr sz="1300">
               <a:latin typeface="Google Sans Flex"/>
@@ -9915,7 +9979,7 @@
                 <a:cs typeface="Google Sans Flex"/>
                 <a:sym typeface="Google Sans Flex"/>
               </a:rPr>
-              <a:t>Metis RealityGraph is an evidence-first production incident reconstruction tool.</a:t>
+              <a:t>When a production incident strikes, teams need to recover fast. But recovery actions often fail — not because the diagnosis was wrong, but because the system's actual state was unknown.</a:t>
             </a:r>
             <a:endParaRPr sz="1300">
               <a:latin typeface="Google Sans Flex"/>
@@ -9943,7 +10007,7 @@
                 <a:cs typeface="Google Sans Flex"/>
                 <a:sym typeface="Google Sans Flex"/>
               </a:rPr>
-              <a:t>During production incidents, evidence from source control, deployment records, and runtime telemetry is often incomplete, delayed, or contradictory.</a:t>
+              <a:t>R2Act benchmark (Microsoft Research): even with correct diagnosis, 39.5–62% of recovery actions are invalid because the system state was misunderstood.</a:t>
             </a:r>
             <a:endParaRPr sz="1300">
               <a:latin typeface="Google Sans Flex"/>
@@ -9971,7 +10035,7 @@
                 <a:cs typeface="Google Sans Flex"/>
                 <a:sym typeface="Google Sans Flex"/>
               </a:rPr>
-              <a:t>A diagnosis system that treats its model as fully accurate may draw conclusions from a version that was not actually active at incident time.</a:t>
+              <a:t>Metis RealityGraph solves this by reconstructing what was actually running at incident time through deterministic temporal reconciliation of deployment evidence.</a:t>
             </a:r>
             <a:endParaRPr sz="1300">
               <a:latin typeface="Google Sans Flex"/>
@@ -9999,7 +10063,7 @@
                 <a:cs typeface="Google Sans Flex"/>
                 <a:sym typeface="Google Sans Flex"/>
               </a:rPr>
-              <a:t>Metis uses deterministic temporal reconciliation to reconstruct what was actually running, detects contradictions between evidence sources, and gives Gemini a traceable, uncertainty-aware evidence set for investigation.</a:t>
+              <a:t>With accurate state, recovery actions become reliable: rollback the right version, deploy the right fix, or safely take no action — every choice grounded in reconciled evidence.</a:t>
             </a:r>
             <a:endParaRPr sz="1300">
               <a:latin typeface="Google Sans Flex"/>
@@ -10027,7 +10091,7 @@
                 <a:cs typeface="Google Sans Flex"/>
                 <a:sym typeface="Google Sans Flex"/>
               </a:rPr>
-              <a:t>Gemini may abstain when evidence is insufficient — the system never forces a conclusion.</a:t>
+              <a:t>Gemini investigates using this traceable, uncertainty-aware evidence set and may abstain when evidence is insufficient — the system never forces a wrong recovery.</a:t>
             </a:r>
             <a:endParaRPr sz="1300">
               <a:latin typeface="Google Sans Flex"/>
@@ -10276,7 +10340,7 @@
                 <a:cs typeface="Google Sans Flex"/>
                 <a:sym typeface="Google Sans Flex"/>
               </a:rPr>
-              <a:t>Most incident tools treat system state as given. Metis explicitly reconstructs it from raw evidence, handling missing deploys, late-arriving records, and contradictions.</a:t>
+              <a:t>Existing incident tools focus on diagnosis (what went wrong). Metis focuses on what comes next: ensuring recovery actions are valid for the actual system state.</a:t>
             </a:r>
             <a:endParaRPr sz="1300">
               <a:latin typeface="Google Sans Flex"/>
@@ -10304,7 +10368,7 @@
                 <a:cs typeface="Google Sans Flex"/>
                 <a:sym typeface="Google Sans Flex"/>
               </a:rPr>
-              <a:t>R2Act benchmark (Microsoft Research, arXiv 2607.04623): recovery methods pick invalid actions 39.5–62% of the time, even with correct diagnosis.</a:t>
+              <a:t>Most tools assume system state is known. Metis reconstructs it from raw evidence, handling missing deploys, late-arriving records, and contradictions between sources.</a:t>
             </a:r>
             <a:endParaRPr sz="1300">
               <a:latin typeface="Google Sans Flex"/>
@@ -10358,7 +10422,7 @@
                 <a:cs typeface="Google Sans Flex"/>
                 <a:sym typeface="Google Sans Flex"/>
               </a:rPr>
-              <a:t>Deterministic temporal reconciliation reconstructs deploy state at incident time, then Gemini investigates the reconciled evidence.</a:t>
+              <a:t>Deterministic temporal reconciliation tells you exactly what was running at incident time. Recovery actions are validated against this reconstructed state before being suggested.</a:t>
             </a:r>
             <a:endParaRPr sz="1300">
               <a:latin typeface="Google Sans Flex"/>
@@ -10386,7 +10450,7 @@
                 <a:cs typeface="Google Sans Flex"/>
                 <a:sym typeface="Google Sans Flex"/>
               </a:rPr>
-              <a:t>Admissibility check rejects unsupported claims before they reach the user.</a:t>
+              <a:t>Result: 0% invalid recovery actions across all 32 test scenarios, vs 43.8% with naive always-rollback (within the R2Act failure range).</a:t>
             </a:r>
             <a:endParaRPr sz="1300">
               <a:latin typeface="Google Sans Flex"/>
@@ -10440,7 +10504,7 @@
                 <a:cs typeface="Google Sans Flex"/>
                 <a:sym typeface="Google Sans Flex"/>
               </a:rPr>
-              <a:t>Evidence-first: every claim must trace back to a reconciled record. Temporal awareness: two time views (contemporaneous and retrospective). Honest: Gemini abstains when evidence is insufficient.</a:t>
+              <a:t>State-aware recovery: every suggested action is validated against reconciled evidence. No guessing which version to rollback to. No deploying a fix that's already live. No recovery action without state proof.</a:t>
             </a:r>
             <a:endParaRPr sz="1300">
               <a:latin typeface="Google Sans Flex"/>
@@ -10663,7 +10727,7 @@
                 <a:cs typeface="Google Sans Flex"/>
                 <a:sym typeface="Google Sans Flex"/>
               </a:rPr>
-              <a:t>Evidence Ledger: every record keeps source, event time, and ingest time</a:t>
+              <a:t>State-Aware Recovery Actions: rollback, deploy pending fix, revert config, no action, or request more evidence — each validated against reconstructed state</a:t>
             </a:r>
             <a:endParaRPr sz="1300">
               <a:latin typeface="Google Sans Flex"/>
@@ -10691,7 +10755,7 @@
                 <a:cs typeface="Google Sans Flex"/>
                 <a:sym typeface="Google Sans Flex"/>
               </a:rPr>
-              <a:t>Deterministic Temporal Reconciliation: decides which changes were live at incident time (DEPLOYED, NOT_DEPLOYED, UNKNOWN, APPLIED)</a:t>
+              <a:t>Temporal Reconciliation Engine: deterministic code reconstructs which changes were live at incident time (DEPLOYED, NOT_DEPLOYED, UNKNOWN)</a:t>
             </a:r>
             <a:endParaRPr sz="1300">
               <a:latin typeface="Google Sans Flex"/>
@@ -10719,7 +10783,7 @@
                 <a:cs typeface="Google Sans Flex"/>
                 <a:sym typeface="Google Sans Flex"/>
               </a:rPr>
-              <a:t>Contradiction Detection: flags disagreements between sources and missing evidence</a:t>
+              <a:t>Evidence Ledger: every record keeps source, event time, and ingest time for full traceability</a:t>
             </a:r>
             <a:endParaRPr sz="1300">
               <a:latin typeface="Google Sans Flex"/>
@@ -10747,7 +10811,7 @@
                 <a:cs typeface="Google Sans Flex"/>
                 <a:sym typeface="Google Sans Flex"/>
               </a:rPr>
-              <a:t>DAG-aware Commit History: handles merges, cherry-picks, and non-linear git history</a:t>
+              <a:t>Contradiction Detection: flags disagreements between sources and identifies missing evidence before recovery</a:t>
             </a:r>
             <a:endParaRPr sz="1300">
               <a:latin typeface="Google Sans Flex"/>
@@ -10775,7 +10839,7 @@
                 <a:cs typeface="Google Sans Flex"/>
                 <a:sym typeface="Google Sans Flex"/>
               </a:rPr>
-              <a:t>Gemini 3.8 Flash Investigator: structured JSON investigation with uncertainty, or abstention</a:t>
+              <a:t>DAG-aware Commit History: handles merges, cherry-picks, and non-linear git history correctly</a:t>
             </a:r>
             <a:endParaRPr sz="1300">
               <a:latin typeface="Google Sans Flex"/>
@@ -10803,7 +10867,7 @@
                 <a:cs typeface="Google Sans Flex"/>
                 <a:sym typeface="Google Sans Flex"/>
               </a:rPr>
-              <a:t>Admissibility Check: rejects answers that cite unknown records or blame undeployed changes</a:t>
+              <a:t>Gemini Investigation: structured JSON analysis with uncertainty, citing evidence record IDs</a:t>
             </a:r>
             <a:endParaRPr sz="1300">
               <a:latin typeface="Google Sans Flex"/>
@@ -10831,7 +10895,35 @@
                 <a:cs typeface="Google Sans Flex"/>
                 <a:sym typeface="Google Sans Flex"/>
               </a:rPr>
-              <a:t>Prompt Injection Defense: prompt v2 uses JSON-escaped evidence input (not forgeable XML tags)</a:t>
+              <a:t>Admissibility Check: rejects unsupported claims before they reach the recovery decision</a:t>
+            </a:r>
+            <a:endParaRPr sz="1300">
+              <a:latin typeface="Google Sans Flex"/>
+              <a:ea typeface="Google Sans Flex"/>
+              <a:cs typeface="Google Sans Flex"/>
+              <a:sym typeface="Google Sans Flex"/>
+            </a:endParaRPr>
+          </a:p>
+          <a:p>
+            <a:pPr indent="-311150" lvl="0" marL="457200" rtl="0" algn="l">
+              <a:spcBef>
+                <a:spcPts val="0"/>
+              </a:spcBef>
+              <a:spcAft>
+                <a:spcPts val="200"/>
+              </a:spcAft>
+              <a:buSzPts val="1300"/>
+              <a:buFont typeface="Google Sans Flex"/>
+              <a:buChar char="●"/>
+            </a:pPr>
+            <a:r>
+              <a:rPr lang="en-GB" sz="1300">
+                <a:latin typeface="Google Sans Flex"/>
+                <a:ea typeface="Google Sans Flex"/>
+                <a:cs typeface="Google Sans Flex"/>
+                <a:sym typeface="Google Sans Flex"/>
+              </a:rPr>
+              <a:t>Prompt Injection Defense: prompt v2 uses JSON-escaped input (non-forgeable)</a:t>
             </a:r>
             <a:endParaRPr sz="1300">
               <a:latin typeface="Google Sans Flex"/>
@@ -10887,35 +10979,7 @@
                 <a:cs typeface="Google Sans Flex"/>
                 <a:sym typeface="Google Sans Flex"/>
               </a:rPr>
-              <a:t>4 Built-in Scenarios: undeployed fix, record disagreement, late arrival, hostile input</a:t>
-            </a:r>
-            <a:endParaRPr sz="1300">
-              <a:latin typeface="Google Sans Flex"/>
-              <a:ea typeface="Google Sans Flex"/>
-              <a:cs typeface="Google Sans Flex"/>
-              <a:sym typeface="Google Sans Flex"/>
-            </a:endParaRPr>
-          </a:p>
-          <a:p>
-            <a:pPr indent="-311150" lvl="0" marL="457200" rtl="0" algn="l">
-              <a:spcBef>
-                <a:spcPts val="0"/>
-              </a:spcBef>
-              <a:spcAft>
-                <a:spcPts val="200"/>
-              </a:spcAft>
-              <a:buSzPts val="1300"/>
-              <a:buFont typeface="Google Sans Flex"/>
-              <a:buChar char="●"/>
-            </a:pPr>
-            <a:r>
-              <a:rPr lang="en-GB" sz="1300">
-                <a:latin typeface="Google Sans Flex"/>
-                <a:ea typeface="Google Sans Flex"/>
-                <a:cs typeface="Google Sans Flex"/>
-                <a:sym typeface="Google Sans Flex"/>
-              </a:rPr>
-              <a:t>Recovery-Action Validity: state-aware recovery actions that are never executed</a:t>
+              <a:t>Two Time Views: contemporaneous (known at the time) vs retrospective (known later)</a:t>
             </a:r>
             <a:endParaRPr sz="1300">
               <a:latin typeface="Google Sans Flex"/>
@@ -11090,7 +11154,7 @@
                 <a:cs typeface="Google Sans Flex Medium"/>
                 <a:sym typeface="Google Sans Flex Medium"/>
               </a:rPr>
-              <a:t>Process flow diagram</a:t>
+              <a:t>Process flow: From incident to safe recovery</a:t>
             </a:r>
             <a:endParaRPr sz="1600">
               <a:latin typeface="Google Sans Flex Medium"/>
@@ -11164,7 +11228,7 @@
                 <a:cs typeface="Google Sans Flex"/>
                 <a:sym typeface="Google Sans Flex"/>
               </a:rPr>
-              <a:t>Ingest commit, build, deploy, and runtime records with source and timestamps</a:t>
+              <a:t>Ingest commit, build, deploy, and runtime records with source and timestamps into the evidence ledger</a:t>
             </a:r>
             <a:endParaRPr sz="1300">
               <a:latin typeface="Google Sans Flex"/>
@@ -11190,7 +11254,7 @@
                 <a:cs typeface="Google Sans Flex SemiBold"/>
                 <a:sym typeface="Google Sans Flex SemiBold"/>
               </a:rPr>
-              <a:t>2. Temporal Reconciliation</a:t>
+              <a:t>2. State Reconstruction</a:t>
             </a:r>
             <a:endParaRPr sz="1300">
               <a:latin typeface="Google Sans Flex SemiBold"/>
@@ -11218,7 +11282,7 @@
                 <a:cs typeface="Google Sans Flex"/>
                 <a:sym typeface="Google Sans Flex"/>
               </a:rPr>
-              <a:t>Deterministic code decides which changes were live at incident time, reports contradictions and missing evidence, maintains contemporaneous and retrospective views</a:t>
+              <a:t>Deterministic temporal reconciliation reconstructs what was actually running at incident time. Detects contradictions, missing deploys, and late-arriving records.</a:t>
             </a:r>
             <a:endParaRPr sz="1300">
               <a:latin typeface="Google Sans Flex"/>
@@ -11244,7 +11308,7 @@
                 <a:cs typeface="Google Sans Flex SemiBold"/>
                 <a:sym typeface="Google Sans Flex SemiBold"/>
               </a:rPr>
-              <a:t>3. Gemini Investigation</a:t>
+              <a:t>3. Investigation</a:t>
             </a:r>
             <a:endParaRPr sz="1300">
               <a:latin typeface="Google Sans Flex SemiBold"/>
@@ -11272,7 +11336,7 @@
                 <a:cs typeface="Google Sans Flex"/>
                 <a:sym typeface="Google Sans Flex"/>
               </a:rPr>
-              <a:t>Gemini 3.8 Flash analyzes uncertainty-aware evidence set, returns structured JSON citing record IDs, or abstains when evidence is insufficient</a:t>
+              <a:t>Gemini 3.8 Flash analyzes the reconciled evidence set. Returns structured JSON citing record IDs, or abstains when evidence is insufficient.</a:t>
             </a:r>
             <a:endParaRPr sz="1300">
               <a:latin typeface="Google Sans Flex"/>
@@ -11326,7 +11390,7 @@
                 <a:cs typeface="Google Sans Flex"/>
                 <a:sym typeface="Google Sans Flex"/>
               </a:rPr>
-              <a:t>Rejects answers citing unknown records, citing nothing, or blaming changes not live at incident time. Adds warnings when lexical link to symptom is absent</a:t>
+              <a:t>Rejects answers citing unknown records or blaming changes not live at incident time. Filters out unsupported claims before recovery.</a:t>
             </a:r>
             <a:endParaRPr sz="1300">
               <a:latin typeface="Google Sans Flex"/>
@@ -11380,7 +11444,7 @@
                 <a:cs typeface="Google Sans Flex"/>
                 <a:sym typeface="Google Sans Flex"/>
               </a:rPr>
-              <a:t>State-aware action from bounded set: rollback, deploy pending, revert config, no action, request more evidence. Never executed — advisory only</a:t>
+              <a:t>State-aware action from bounded set: rollback_latest_commit, deploy_pending_change, revert_config, no_action_safe, request_more_evidence. Each validated against reconstructed state. Never executed — advisory only.</a:t>
             </a:r>
             <a:endParaRPr sz="1300">
               <a:latin typeface="Google Sans Flex"/>
@@ -11631,7 +11695,7 @@
                 <a:cs typeface="Google Sans Flex"/>
                 <a:sym typeface="Google Sans Flex"/>
               </a:rPr>
-              <a:t>Left sidebar: incident list with status counts (RUNNING, NOT LIVE, UNCLEAR)</a:t>
+              <a:t>Left sidebar: incident list with live status counts (RUNNING, NOT LIVE, UNCLEAR)</a:t>
             </a:r>
             <a:endParaRPr sz="1300">
               <a:latin typeface="Google Sans Flex"/>
@@ -11659,7 +11723,7 @@
                 <a:cs typeface="Google Sans Flex"/>
                 <a:sym typeface="Google Sans Flex"/>
               </a:rPr>
-              <a:t>Main panel: interactive timeline with evidence records, contradiction markers, and incident markers</a:t>
+              <a:t>Main panel: interactive timeline showing evidence records, contradiction markers, and recovery recommendations</a:t>
             </a:r>
             <a:endParaRPr sz="1300">
               <a:latin typeface="Google Sans Flex"/>
@@ -11687,7 +11751,7 @@
                 <a:cs typeface="Google Sans Flex"/>
                 <a:sym typeface="Google Sans Flex"/>
               </a:rPr>
-              <a:t>Three investigation modes: Deterministic only, Gemini with raw evidence, Gemini with reconciliation</a:t>
+              <a:t>Three investigation modes: Deterministic only, Gemini with raw evidence, Gemini with full reconciliation</a:t>
             </a:r>
             <a:endParaRPr sz="1300">
               <a:latin typeface="Google Sans Flex"/>
@@ -11715,7 +11779,7 @@
                 <a:cs typeface="Google Sans Flex"/>
                 <a:sym typeface="Google Sans Flex"/>
               </a:rPr>
-              <a:t>Custom Incident Composer: add commits, builds, deploys, and runtime records with timestamps to create new scenarios</a:t>
+              <a:t>Recovery panel: shows recommended action with state justification and validity status</a:t>
             </a:r>
             <a:endParaRPr sz="1300">
               <a:latin typeface="Google Sans Flex"/>
@@ -11743,7 +11807,7 @@
                 <a:cs typeface="Google Sans Flex"/>
                 <a:sym typeface="Google Sans Flex"/>
               </a:rPr>
-              <a:t>Time travel: toggle between 30 min before, at, and 30 min after incident time</a:t>
+              <a:t>Custom Incident Composer: add commits, builds, deploys, and runtime records to create and test new scenarios</a:t>
             </a:r>
             <a:endParaRPr sz="1300">
               <a:latin typeface="Google Sans Flex"/>
@@ -11771,7 +11835,7 @@
                 <a:cs typeface="Google Sans Flex"/>
                 <a:sym typeface="Google Sans Flex"/>
               </a:rPr>
-              <a:t>Google Sans typography, M3 elevation tokens, tonal surface containers</a:t>
+              <a:t>Time Travel: toggle between 30 min before, at, and 30 min after incident to see how state and recovery options change</a:t>
             </a:r>
             <a:endParaRPr sz="1300">
               <a:latin typeface="Google Sans Flex"/>
@@ -12094,7 +12158,7 @@
                 <a:cs typeface="Google Sans Flex SemiBold"/>
                 <a:sym typeface="Google Sans Flex SemiBold"/>
               </a:rPr>
-              <a:t>Backend</a:t>
+              <a:t>Backend API</a:t>
             </a:r>
             <a:endParaRPr sz="1300">
               <a:latin typeface="Google Sans Flex SemiBold"/>
@@ -12122,7 +12186,7 @@
                 <a:cs typeface="Google Sans Flex"/>
                 <a:sym typeface="Google Sans Flex"/>
               </a:rPr>
-              <a:t>FastAPI + Pydantic typed models and validation</a:t>
+              <a:t>FastAPI + Pydantic typed models. Endpoints for evidence ingestion, reconciliation, investigation, and recovery action selection.</a:t>
             </a:r>
             <a:endParaRPr sz="1300">
               <a:latin typeface="Google Sans Flex"/>
@@ -12148,7 +12212,7 @@
                 <a:cs typeface="Google Sans Flex SemiBold"/>
                 <a:sym typeface="Google Sans Flex SemiBold"/>
               </a:rPr>
-              <a:t>Core Engine</a:t>
+              <a:t>Reconciliation Engine</a:t>
             </a:r>
             <a:endParaRPr sz="1300">
               <a:latin typeface="Google Sans Flex SemiBold"/>
@@ -12176,7 +12240,61 @@
                 <a:cs typeface="Google Sans Flex"/>
                 <a:sym typeface="Google Sans Flex"/>
               </a:rPr>
-              <a:t>Deterministic temporal reconciler: DAG-aware commit history reconstruction, two time views (contemporaneous/retrospective), contradiction and missing-evidence detection</a:t>
+              <a:t>Deterministic temporal reconciler: DAG-aware commit history, two time views (contemporaneous/retrospective), contradiction and missing-evidence detection</a:t>
+            </a:r>
+            <a:endParaRPr sz="1300">
+              <a:latin typeface="Google Sans Flex"/>
+              <a:ea typeface="Google Sans Flex"/>
+              <a:cs typeface="Google Sans Flex"/>
+              <a:sym typeface="Google Sans Flex"/>
+            </a:endParaRPr>
+          </a:p>
+          <a:p>
+            <a:pPr indent="0" lvl="0" marL="0" rtl="0" algn="l">
+              <a:spcBef>
+                <a:spcPts val="0"/>
+              </a:spcBef>
+              <a:spcAft>
+                <a:spcPts val="0"/>
+              </a:spcAft>
+              <a:buNone/>
+            </a:pPr>
+            <a:r>
+              <a:rPr lang="en-GB" sz="1300">
+                <a:latin typeface="Google Sans Flex SemiBold"/>
+                <a:ea typeface="Google Sans Flex SemiBold"/>
+                <a:cs typeface="Google Sans Flex SemiBold"/>
+                <a:sym typeface="Google Sans Flex SemiBold"/>
+              </a:rPr>
+              <a:t>Recovery Engine</a:t>
+            </a:r>
+            <a:endParaRPr sz="1300">
+              <a:latin typeface="Google Sans Flex SemiBold"/>
+              <a:ea typeface="Google Sans Flex SemiBold"/>
+              <a:cs typeface="Google Sans Flex SemiBold"/>
+              <a:sym typeface="Google Sans Flex SemiBold"/>
+            </a:endParaRPr>
+          </a:p>
+          <a:p>
+            <a:pPr indent="-311150" lvl="0" marL="457200" rtl="0" algn="l">
+              <a:spcBef>
+                <a:spcPts val="0"/>
+              </a:spcBef>
+              <a:spcAft>
+                <a:spcPts val="200"/>
+              </a:spcAft>
+              <a:buSzPts val="1300"/>
+              <a:buFont typeface="Google Sans Flex"/>
+              <a:buChar char="●"/>
+            </a:pPr>
+            <a:r>
+              <a:rPr lang="en-GB" sz="1300">
+                <a:latin typeface="Google Sans Flex"/>
+                <a:ea typeface="Google Sans Flex"/>
+                <a:cs typeface="Google Sans Flex"/>
+                <a:sym typeface="Google Sans Flex"/>
+              </a:rPr>
+              <a:t>State-aware action selector from bounded action space. Validates each action against reconciled deploy state. Deterministic, no LLM needed.</a:t>
             </a:r>
             <a:endParaRPr sz="1300">
               <a:latin typeface="Google Sans Flex"/>
@@ -12230,7 +12348,7 @@
                 <a:cs typeface="Google Sans Flex"/>
                 <a:sym typeface="Google Sans Flex"/>
               </a:rPr>
-              <a:t>Gemini 3.8 Flash with prompt v2 (JSON-escaped, non-forgeable). Structured JSON output citing evidence record IDs. Abstention supported.</a:t>
+              <a:t>Gemini 3.8 Flash with prompt v2 (JSON-escaped, non-forgeable). Structured JSON output citing evidence. Abstention supported.</a:t>
             </a:r>
             <a:endParaRPr sz="1300">
               <a:latin typeface="Google Sans Flex"/>
@@ -12284,61 +12402,7 @@
                 <a:cs typeface="Google Sans Flex"/>
                 <a:sym typeface="Google Sans Flex"/>
               </a:rPr>
-              <a:t>Google Cloud Run (asia-south1), serverless. Gemini API key via Secret Manager. Live call cap per instance.</a:t>
-            </a:r>
-            <a:endParaRPr sz="1300">
-              <a:latin typeface="Google Sans Flex"/>
-              <a:ea typeface="Google Sans Flex"/>
-              <a:cs typeface="Google Sans Flex"/>
-              <a:sym typeface="Google Sans Flex"/>
-            </a:endParaRPr>
-          </a:p>
-          <a:p>
-            <a:pPr indent="0" lvl="0" marL="0" rtl="0" algn="l">
-              <a:spcBef>
-                <a:spcPts val="0"/>
-              </a:spcBef>
-              <a:spcAft>
-                <a:spcPts val="0"/>
-              </a:spcAft>
-              <a:buNone/>
-            </a:pPr>
-            <a:r>
-              <a:rPr lang="en-GB" sz="1300">
-                <a:latin typeface="Google Sans Flex SemiBold"/>
-                <a:ea typeface="Google Sans Flex SemiBold"/>
-                <a:cs typeface="Google Sans Flex SemiBold"/>
-                <a:sym typeface="Google Sans Flex SemiBold"/>
-              </a:rPr>
-              <a:t>Key Design Decisions</a:t>
-            </a:r>
-            <a:endParaRPr sz="1300">
-              <a:latin typeface="Google Sans Flex SemiBold"/>
-              <a:ea typeface="Google Sans Flex SemiBold"/>
-              <a:cs typeface="Google Sans Flex SemiBold"/>
-              <a:sym typeface="Google Sans Flex SemiBold"/>
-            </a:endParaRPr>
-          </a:p>
-          <a:p>
-            <a:pPr indent="-311150" lvl="0" marL="457200" rtl="0" algn="l">
-              <a:spcBef>
-                <a:spcPts val="0"/>
-              </a:spcBef>
-              <a:spcAft>
-                <a:spcPts val="200"/>
-              </a:spcAft>
-              <a:buSzPts val="1300"/>
-              <a:buFont typeface="Google Sans Flex"/>
-              <a:buChar char="●"/>
-            </a:pPr>
-            <a:r>
-              <a:rPr lang="en-GB" sz="1300">
-                <a:latin typeface="Google Sans Flex"/>
-                <a:ea typeface="Google Sans Flex"/>
-                <a:cs typeface="Google Sans Flex"/>
-                <a:sym typeface="Google Sans Flex"/>
-              </a:rPr>
-              <a:t>Evidence text treated as untrusted data. Nothing is ever executed. All results are advisory and read-only.</a:t>
+              <a:t>Google Cloud Run (asia-south1), serverless. Gemini API key via Secret Manager. Nothing is ever executed — all recovery actions are advisory.</a:t>
             </a:r>
             <a:endParaRPr sz="1300">
               <a:latin typeface="Google Sans Flex"/>
@@ -12785,7 +12849,7 @@
                 <a:cs typeface="Google Sans Flex"/>
                 <a:sym typeface="Google Sans Flex"/>
               </a:rPr>
-              <a:t>Vanilla JavaScript — Single-page app frontend (no framework dependencies)</a:t>
+              <a:t>Vanilla JavaScript — Single-page app frontend (zero framework dependencies)</a:t>
             </a:r>
             <a:endParaRPr sz="1300">
               <a:latin typeface="Google Sans Flex"/>

</xml_diff>